<commit_message>
Enhance spatial weights sensitivity analysis
</commit_message>
<xml_diff>
--- a/slides/Wisconsin_PM25_Spatial_Analysis.pptx
+++ b/slides/Wisconsin_PM25_Spatial_Analysis.pptx
@@ -4709,7 +4709,7 @@
               </a:defRPr>
             </a:pPr>
             <a:r>
-              <a:t>Sensitivity, Limitations, and Conclusion</a:t>
+              <a:t>Are the Spatial Results Robust?</a:t>
             </a:r>
           </a:p>
         </p:txBody>
@@ -4723,7 +4723,7 @@
         <p:spPr>
           <a:xfrm>
             <a:off x="548640" y="914400"/>
-            <a:ext cx="4937760" cy="5303520"/>
+            <a:ext cx="4937760" cy="2194560"/>
           </a:xfrm>
           <a:prstGeom prst="rect">
             <a:avLst/>
@@ -4731,48 +4731,130 @@
           <a:noFill/>
         </p:spPr>
         <p:txBody>
-          <a:bodyPr wrap="square">
+          <a:bodyPr wrap="none">
             <a:spAutoFit/>
           </a:bodyPr>
           <a:lstStyle/>
           <a:p>
             <a:pPr>
               <a:spcAft>
-                <a:spcPts val="1000"/>
+                <a:spcPts val="300"/>
               </a:spcAft>
-              <a:defRPr sz="1800"/>
+              <a:defRPr sz="1150">
+                <a:latin typeface="Menlo"/>
+              </a:defRPr>
             </a:pPr>
             <a:r>
-              <a:t>KNN weights remove zero-neighbor counties.</a:t>
+              <a:t>Spec      I        p      comps  islands</a:t>
             </a:r>
           </a:p>
           <a:p>
             <a:pPr>
               <a:spcAft>
-                <a:spcPts val="1000"/>
+                <a:spcPts val="300"/>
               </a:spcAft>
-              <a:defRPr sz="1800"/>
+              <a:defRPr sz="1150">
+                <a:latin typeface="Menlo"/>
+              </a:defRPr>
             </a:pPr>
             <a:r>
-              <a:t>Sparse coverage limits statewide inference.</a:t>
+              <a:t>Queen     -0.140  0.402      8        5</a:t>
             </a:r>
           </a:p>
           <a:p>
             <a:pPr>
               <a:spcAft>
-                <a:spcPts val="1000"/>
+                <a:spcPts val="300"/>
               </a:spcAft>
-              <a:defRPr sz="1800"/>
+              <a:defRPr sz="1150">
+                <a:latin typeface="Menlo"/>
+              </a:defRPr>
             </a:pPr>
             <a:r>
-              <a:t>The most defensible conclusion is descriptive rather than causal or regulatory.</a:t>
+              <a:t>KNN3      -0.097  0.461      1        0</a:t>
+            </a:r>
+          </a:p>
+          <a:p>
+            <a:pPr>
+              <a:spcAft>
+                <a:spcPts val="300"/>
+              </a:spcAft>
+              <a:defRPr sz="1150">
+                <a:latin typeface="Menlo"/>
+              </a:defRPr>
+            </a:pPr>
+            <a:r>
+              <a:t>KNN4      -0.080  0.476      1        0</a:t>
+            </a:r>
+          </a:p>
+          <a:p>
+            <a:pPr>
+              <a:spcAft>
+                <a:spcPts val="300"/>
+              </a:spcAft>
+              <a:defRPr sz="1150">
+                <a:latin typeface="Menlo"/>
+              </a:defRPr>
+            </a:pPr>
+            <a:r>
+              <a:t>KNN5      -0.029  0.307      1        0</a:t>
+            </a:r>
+          </a:p>
+        </p:txBody>
+      </p:sp>
+      <p:sp>
+        <p:nvSpPr>
+          <p:cNvPr id="4" name="Rounded Rectangle 3"/>
+          <p:cNvSpPr/>
+          <p:nvPr/>
+        </p:nvSpPr>
+        <p:spPr>
+          <a:xfrm>
+            <a:off x="548640" y="4846320"/>
+            <a:ext cx="4937760" cy="1188720"/>
+          </a:xfrm>
+          <a:prstGeom prst="roundRect">
+            <a:avLst/>
+          </a:prstGeom>
+          <a:solidFill>
+            <a:srgbClr val="F8EFDD"/>
+          </a:solidFill>
+          <a:ln>
+            <a:solidFill>
+              <a:srgbClr val="981C24"/>
+            </a:solidFill>
+          </a:ln>
+        </p:spPr>
+        <p:style>
+          <a:lnRef idx="1">
+            <a:schemeClr val="accent1"/>
+          </a:lnRef>
+          <a:fillRef idx="3">
+            <a:schemeClr val="accent1"/>
+          </a:fillRef>
+          <a:effectRef idx="2">
+            <a:schemeClr val="accent1"/>
+          </a:effectRef>
+          <a:fontRef idx="minor">
+            <a:schemeClr val="lt1"/>
+          </a:fontRef>
+        </p:style>
+        <p:txBody>
+          <a:bodyPr rtlCol="0" anchor="ctr"/>
+          <a:lstStyle/>
+          <a:p>
+            <a:pPr algn="ctr">
+              <a:defRPr sz="1500" b="1"/>
+            </a:pPr>
+            <a:r>
+              <a:t>No significant global clustering under any tested spatial-weight definition; local cluster labels are sensitive to the neighborhood specification.</a:t>
             </a:r>
           </a:p>
         </p:txBody>
       </p:sp>
       <p:pic>
         <p:nvPicPr>
-          <p:cNvPr id="4" name="Picture 3" descr="lisa_cluster_map_knn4.png"/>
+          <p:cNvPr id="5" name="Picture 4" descr="global_moran_sensitivity.png"/>
           <p:cNvPicPr>
             <a:picLocks noChangeAspect="1"/>
           </p:cNvPicPr>
@@ -4787,7 +4869,7 @@
         <p:spPr>
           <a:xfrm>
             <a:off x="5669280" y="1005840"/>
-            <a:ext cx="5943600" cy="6373294"/>
+            <a:ext cx="5943600" cy="3848296"/>
           </a:xfrm>
           <a:prstGeom prst="rect">
             <a:avLst/>
@@ -4796,7 +4878,7 @@
       </p:pic>
       <p:sp>
         <p:nvSpPr>
-          <p:cNvPr id="5" name="TextBox 4"/>
+          <p:cNvPr id="6" name="TextBox 5"/>
           <p:cNvSpPr txBox="1"/>
           <p:nvPr/>
         </p:nvSpPr>

</xml_diff>